<commit_message>
docs: talk decks use the current cyberpunk logo
</commit_message>
<xml_diff>
--- a/docs/talk-devs.pptx
+++ b/docs/talk-devs.pptx
@@ -161,7 +161,7 @@
   <p:extLst>
     <p:ext uri="{521415D9-36F7-43E2-AB2F-B90AF26B5E84}">
       <p14:sectionLst xmlns:p14="http://schemas.microsoft.com/office/powerpoint/2010/main">
-        <p14:section name="Orientation" id="{834a229d-52de-1424-0555-2c876c50982f}">
+        <p14:section name="Orientation" id="{99ae78b8-bd46-9fda-8c67-a34bba4f80c8}">
           <p14:sldIdLst>
             <p14:sldId id="256"/>
             <p14:sldId id="257"/>
@@ -171,7 +171,7 @@
             <p14:sldId id="261"/>
           </p14:sldIdLst>
         </p14:section>
-        <p14:section name="Porting rules" id="{c0422c7b-edb2-2739-8c04-8e21998b4391}">
+        <p14:section name="Porting rules" id="{dac8af97-937b-d419-787b-33cb86d6f91c}">
           <p14:sldIdLst>
             <p14:sldId id="262"/>
             <p14:sldId id="263"/>
@@ -183,7 +183,7 @@
             <p14:sldId id="269"/>
           </p14:sldIdLst>
         </p14:section>
-        <p14:section name="State model" id="{606d39c6-697a-44d3-4082-f47b0a0cae8c}">
+        <p14:section name="State model" id="{dc515307-8c28-d744-94e2-2a2e0e6468bb}">
           <p14:sldIdLst>
             <p14:sldId id="270"/>
             <p14:sldId id="271"/>
@@ -192,7 +192,7 @@
             <p14:sldId id="274"/>
           </p14:sldIdLst>
         </p14:section>
-        <p14:section name="Execution" id="{ad907e93-6fbe-81f9-d9bc-4b14af181420}">
+        <p14:section name="Execution" id="{08d4a984-6c6a-cc2e-480e-eeaf538ade1b}">
           <p14:sldIdLst>
             <p14:sldId id="275"/>
             <p14:sldId id="276"/>
@@ -203,7 +203,7 @@
             <p14:sldId id="281"/>
           </p14:sldIdLst>
         </p14:section>
-        <p14:section name="Caches and daemon" id="{9c427c70-373c-8e37-db1e-e251050a9549}">
+        <p14:section name="Caches and daemon" id="{74dd974f-bcfe-a161-4e7a-dff2e3c5f6ec}">
           <p14:sldIdLst>
             <p14:sldId id="282"/>
             <p14:sldId id="283"/>
@@ -213,7 +213,7 @@
             <p14:sldId id="287"/>
           </p14:sldIdLst>
         </p14:section>
-        <p14:section name="Extensibility" id="{db072c42-c13c-9206-07f6-8609a6f4871a}">
+        <p14:section name="Extensibility" id="{baaabf6f-fb0b-93b0-2f97-8ebe52f49ea6}">
           <p14:sldIdLst>
             <p14:sldId id="288"/>
             <p14:sldId id="289"/>
@@ -225,7 +225,7 @@
             <p14:sldId id="295"/>
           </p14:sldIdLst>
         </p14:section>
-        <p14:section name="Testing" id="{70aba057-6916-35c9-f6b9-a9ff5036ccdd}">
+        <p14:section name="Testing" id="{67b05f85-aaaa-e97d-abe0-867d866c6ae3}">
           <p14:sldIdLst>
             <p14:sldId id="296"/>
             <p14:sldId id="297"/>
@@ -235,7 +235,7 @@
             <p14:sldId id="301"/>
           </p14:sldIdLst>
         </p14:section>
-        <p14:section name="Debugging" id="{c8e3c6f3-e1db-c9e2-3a8a-6cf089228043}">
+        <p14:section name="Debugging" id="{e26f2310-d3fd-6646-be7d-90c7ff6ee872}">
           <p14:sldIdLst>
             <p14:sldId id="302"/>
             <p14:sldId id="303"/>
@@ -244,7 +244,7 @@
             <p14:sldId id="306"/>
           </p14:sldIdLst>
         </p14:section>
-        <p14:section name="Contributing" id="{7adf3746-9f2e-2fd0-314e-35ca4559e4fd}">
+        <p14:section name="Contributing" id="{ccc9a4da-315b-d482-a099-872cbd74acce}">
           <p14:sldIdLst>
             <p14:sldId id="307"/>
             <p14:sldId id="308"/>
@@ -5506,7 +5506,7 @@
       </p:grpSpPr>
       <p:pic>
         <p:nvPicPr>
-          <p:cNvPr id="2" name="Image 0" descr="/private/tmp/claude-501/-Users-wizard-RustroverProjects-zshrs/2555d359-9a79-4736-9207-869cc21577b1/scratchpad/logo/logo-mark.png">    </p:cNvPr>
+          <p:cNvPr id="2" name="Image 0" descr="/Users/wizard/RustroverProjects/zshrs/docs/logo-mark.png">    </p:cNvPr>
           <p:cNvPicPr>
             <a:picLocks noChangeAspect="1"/>
           </p:cNvPicPr>
@@ -5649,7 +5649,7 @@
       </p:grpSpPr>
       <p:pic>
         <p:nvPicPr>
-          <p:cNvPr id="2" name="Image 0" descr="/private/tmp/claude-501/-Users-wizard-RustroverProjects-zshrs/2555d359-9a79-4736-9207-869cc21577b1/scratchpad/logo/logo-mark.png">    </p:cNvPr>
+          <p:cNvPr id="2" name="Image 0" descr="/Users/wizard/RustroverProjects/zshrs/docs/logo-mark.png">    </p:cNvPr>
           <p:cNvPicPr>
             <a:picLocks noChangeAspect="1"/>
           </p:cNvPicPr>
@@ -6112,7 +6112,7 @@
       </p:grpSpPr>
       <p:pic>
         <p:nvPicPr>
-          <p:cNvPr id="3" name="Image 0" descr="/private/tmp/claude-501/-Users-wizard-RustroverProjects-zshrs/2555d359-9a79-4736-9207-869cc21577b1/scratchpad/logo/logo.png">    </p:cNvPr>
+          <p:cNvPr id="3" name="Image 0" descr="/Users/wizard/RustroverProjects/zshrs/docs/logo.png">    </p:cNvPr>
           <p:cNvPicPr>
             <a:picLocks noChangeAspect="1"/>
           </p:cNvPicPr>
@@ -38818,7 +38818,7 @@
       </p:grpSpPr>
       <p:pic>
         <p:nvPicPr>
-          <p:cNvPr id="3" name="Image 0" descr="/private/tmp/claude-501/-Users-wizard-RustroverProjects-zshrs/2555d359-9a79-4736-9207-869cc21577b1/scratchpad/logo/logo.png">    </p:cNvPr>
+          <p:cNvPr id="3" name="Image 0" descr="/Users/wizard/RustroverProjects/zshrs/docs/logo.png">    </p:cNvPr>
           <p:cNvPicPr>
             <a:picLocks noChangeAspect="1"/>
           </p:cNvPicPr>

</xml_diff>